<commit_message>
Print the repository address on the deck instead of a placeholder
Slide 6 ended on the literal text [REPO URL]. It now carries the
address, as a hyperlink and as readable text, so it survives being
printed or exported to PDF.

The stack line here is left alone: unlike the companion submission,
this project really does depend on PyTorch - the world model and the
integrated-gradients attribution are both written against it.

Team ID on slide 1 is still a placeholder.
</commit_message>
<xml_diff>
--- a/submission/SIH2026_SIH26153_KALACHAKRA_idea.pptx
+++ b/submission/SIH2026_SIH26153_KALACHAKRA_idea.pptx
@@ -11312,7 +11312,17 @@
                 </a:solidFill>
                 <a:latin typeface="Calibri"/>
               </a:rPr>
-              <a:t>Repository with all experiments, pre-registered predictions and printed verdicts, and one-command reproduction: [REPO URL]</a:t>
+              <a:t>Repository with all experiments, pre-registered predictions and printed verdicts, and one-command reproduction:</a:t>
+            </a:r>
+            <a:r>
+              <a:rPr sz="1000" b="0" u="sng">
+                <a:solidFill>
+                  <a:srgbClr val="2E4A7D"/>
+                </a:solidFill>
+                <a:latin typeface="Calibri"/>
+                <a:hlinkClick r:id="rId4"/>
+              </a:rPr>
+              <a:t>  github.com/AKRai-2005/kalachakra</a:t>
             </a:r>
           </a:p>
         </p:txBody>

</xml_diff>